<commit_message>
Notebook executado ponta a ponta + números atualizados em todos os materiais
Sprint3_Multiabordagem_Forzy.ipynb agora sobe com as 3 abordagens
executadas de verdade (resultados_brutos e acuracia_sprint3 gerados
pela própria execução, sem erros). O GPT-4o não é determinístico e a
acurácia dele variou ligeiramente entre execuções (85,3% -> 84,7%);
relatório técnico, README e slides foram atualizados para refletir
exatamente os números desta execução, incluindo os dois casos de
alucinação (placa_teste_25 e placa_teste_29, este último agora com
dois campos inventados na mesma imagem).
</commit_message>
<xml_diff>
--- a/apresentacao_sprint3.pptx
+++ b/apresentacao_sprint3.pptx
@@ -3642,7 +3642,7 @@
                 </a:solidFill>
                 <a:latin typeface="Arial Black"/>
               </a:rPr>
-              <a:t>85,3% x 82,7% x 80,0%</a:t>
+              <a:t>84,7% x 82,7% x 80,0%</a:t>
             </a:r>
           </a:p>
         </p:txBody>
@@ -3817,7 +3817,7 @@
                           </a:solidFill>
                           <a:latin typeface="Consolas"/>
                         </a:rPr>
-                        <a:t>85,3%</a:t>
+                        <a:t>84,7%</a:t>
                       </a:r>
                     </a:p>
                   </a:txBody>
@@ -3840,7 +3840,7 @@
                           </a:solidFill>
                           <a:latin typeface="Consolas"/>
                         </a:rPr>
-                        <a:t>0,240</a:t>
+                        <a:t>0,251</a:t>
                       </a:r>
                     </a:p>
                   </a:txBody>
@@ -4084,7 +4084,7 @@
                 </a:solidFill>
                 <a:latin typeface="Arial"/>
               </a:rPr>
-              <a:t>Este número é inflado: 21 das 30 imagens têm gabarito “N/A” em tudo, e acertar “não há nada pra ler” conta como acerto pras três abordagens igualmente. O sinal de verdade está no próximo slide.</a:t>
+              <a:t>Este número é inflado: 21 das 30 imagens têm gabarito “N/A” em tudo, e acertar “não há nada pra ler” conta como acerto pras três abordagens igualmente. O CER do GPT-4o (0,251) já fica bem próximo do EasyOCR (0,253) — o sinal de verdade está no próximo slide.</a:t>
             </a:r>
           </a:p>
         </p:txBody>
@@ -4933,7 +4933,7 @@
                           </a:solidFill>
                           <a:latin typeface="Consolas"/>
                         </a:rPr>
-                        <a:t>75,0%</a:t>
+                        <a:t>50,0%</a:t>
                       </a:r>
                     </a:p>
                   </a:txBody>
@@ -5737,7 +5737,7 @@
                 </a:solidFill>
                 <a:latin typeface="Arial"/>
               </a:rPr>
-              <a:t>. GPT-4o “inventou” fabricante = </a:t>
+              <a:t>. GPT-4o “inventou” modelo = </a:t>
             </a:r>
             <a:r>
               <a:rPr sz="1250" b="1" i="0">
@@ -5746,7 +5746,7 @@
                 </a:solidFill>
                 <a:latin typeface="Arial"/>
               </a:rPr>
-              <a:t>"K2"</a:t>
+              <a:t>"K2 SPARE COOK..."</a:t>
             </a:r>
             <a:r>
               <a:rPr sz="1250" b="0" i="0">
@@ -5755,7 +5755,7 @@
                 </a:solidFill>
                 <a:latin typeface="Arial"/>
               </a:rPr>
-              <a:t> e número de série a partir do código de localização funcional da tag — nenhum dos dois é real.</a:t>
+              <a:t> a partir do código de localização funcional da tag — não é um modelo real.</a:t>
             </a:r>
           </a:p>
         </p:txBody>
@@ -5866,7 +5866,7 @@
                 </a:solidFill>
                 <a:latin typeface="Arial"/>
               </a:rPr>
-              <a:t>numero_serie = "150-536"</a:t>
+              <a:t>DOIS</a:t>
             </a:r>
             <a:r>
               <a:rPr sz="1250" b="0" i="0">
@@ -5875,7 +5875,43 @@
                 </a:solidFill>
                 <a:latin typeface="Arial"/>
               </a:rPr>
-              <a:t> sem base visível nenhuma na imagem.</a:t>
+              <a:t> valores inventados: </a:t>
+            </a:r>
+            <a:r>
+              <a:rPr sz="1250" b="1" i="0">
+                <a:solidFill>
+                  <a:srgbClr val="A8432A"/>
+                </a:solidFill>
+                <a:latin typeface="Arial"/>
+              </a:rPr>
+              <a:t>numero_serie = "150036"</a:t>
+            </a:r>
+            <a:r>
+              <a:rPr sz="1250" b="0" i="0">
+                <a:solidFill>
+                  <a:srgbClr val="1C1915"/>
+                </a:solidFill>
+                <a:latin typeface="Arial"/>
+              </a:rPr>
+              <a:t> e </a:t>
+            </a:r>
+            <a:r>
+              <a:rPr sz="1250" b="1" i="0">
+                <a:solidFill>
+                  <a:srgbClr val="A8432A"/>
+                </a:solidFill>
+                <a:latin typeface="Arial"/>
+              </a:rPr>
+              <a:t>potencia = "3 HP"</a:t>
+            </a:r>
+            <a:r>
+              <a:rPr sz="1250" b="0" i="0">
+                <a:solidFill>
+                  <a:srgbClr val="1C1915"/>
+                </a:solidFill>
+                <a:latin typeface="Arial"/>
+              </a:rPr>
+              <a:t>.</a:t>
             </a:r>
           </a:p>
         </p:txBody>
@@ -6338,7 +6374,7 @@
                 </a:solidFill>
                 <a:latin typeface="Arial"/>
               </a:rPr>
-              <a:t>GPT-4o tem custo por chamada e aluciona com confiança em placas ilegíveis</a:t>
+              <a:t>GPT-4o não é determinístico e aluciona com confiança em placas ilegíveis (às vezes em 2 campos na mesma imagem)</a:t>
             </a:r>
           </a:p>
           <a:p>

</xml_diff>